<commit_message>
feat: outline 风格 + SVG 矢量库 + PPTX 嵌入 SVG (粘贴不再填色方框)
- 图标改用 Material Symbols outline-rounded 风格,改色只染线条,中间透明
- 新增 assets/svg/{蓝/橙/红}/ 共 300 个 SVG 矢量文件,文件名 NN_中文名.svg
  可直接拖进 PPT/Word/Notion/Figma,粘贴不会填满方框
- PPTX 嵌入 SVG (asvg:svgBlip 扩展) + PNG 兜底
  PowerPoint 2016+ 显示矢量,可右键改色、放大不糊
  老版 PPT/WPS 自动用 PNG 显示
- 验证: 124 个 svg 内嵌, 所有 a:blip 都挂上了 svgBlip
- icons.py 增加 STYLE 配置,可在 outline-rounded / filled-rounded 间切换
</commit_message>
<xml_diff>
--- a/assets/icon_library.pptx
+++ b/assets/icon_library.pptx
@@ -3175,7 +3175,7 @@
                 </a:solidFill>
                 <a:latin typeface="Microsoft YaHei"/>
               </a:rPr>
-              <a:t>图标库 · 100 选 · 三色对照</a:t>
+              <a:t>图标库 · 100 选 · 三色对照 · 矢量版</a:t>
             </a:r>
           </a:p>
         </p:txBody>
@@ -3210,7 +3210,7 @@
                 </a:solidFill>
                 <a:latin typeface="Microsoft YaHei"/>
               </a:rPr>
-              <a:t>Material Symbols · 8 大业务场景 · 256px 源图</a:t>
+              <a:t>Material Symbols Outline · SVG 矢量嵌入 · 改色不会填满方框</a:t>
             </a:r>
           </a:p>
         </p:txBody>
@@ -3593,7 +3593,7 @@
                 </a:solidFill>
                 <a:latin typeface="Microsoft YaHei"/>
               </a:rPr>
-              <a:t>共 100 个图标 · 8 大分组</a:t>
+              <a:t>共 100 个图标 · 8 大分组 · 每图 3 色</a:t>
             </a:r>
           </a:p>
         </p:txBody>
@@ -3663,7 +3663,7 @@
                 </a:solidFill>
                 <a:latin typeface="Microsoft YaHei"/>
               </a:rPr>
-              <a:t>每页 12 图 · 卡片化布局 · 图标 1.5×</a:t>
+              <a:t>PPT 2016+ 显示为矢量,粘到文档不会出现填色方块</a:t>
             </a:r>
           </a:p>
         </p:txBody>
@@ -3797,7 +3797,7 @@
                 </a:solidFill>
                 <a:latin typeface="Microsoft YaHei"/>
               </a:rPr>
-              <a:t>色:深蓝灰   ·   一页 12 图</a:t>
+              <a:t>色:深蓝灰   ·   一页 12 图   ·   矢量</a:t>
             </a:r>
           </a:p>
         </p:txBody>
@@ -3859,7 +3859,13 @@
           <p:nvPr/>
         </p:nvPicPr>
         <p:blipFill>
-          <a:blip r:embed="rId2"/>
+          <a:blip r:embed="rId2">
+            <a:extLst>
+              <a:ext uri="{96DAC541-7B7A-43D3-8B79-37D633B846F1}">
+                <asvg:svgBlip xmlns:asvg="http://schemas.microsoft.com/office/drawing/2016/SVG/main" r:embed="rId3"/>
+              </a:ext>
+            </a:extLst>
+          </a:blip>
           <a:stretch>
             <a:fillRect/>
           </a:stretch>
@@ -4001,7 +4007,13 @@
           <p:nvPr/>
         </p:nvPicPr>
         <p:blipFill>
-          <a:blip r:embed="rId3"/>
+          <a:blip r:embed="rId4">
+            <a:extLst>
+              <a:ext uri="{96DAC541-7B7A-43D3-8B79-37D633B846F1}">
+                <asvg:svgBlip xmlns:asvg="http://schemas.microsoft.com/office/drawing/2016/SVG/main" r:embed="rId5"/>
+              </a:ext>
+            </a:extLst>
+          </a:blip>
           <a:stretch>
             <a:fillRect/>
           </a:stretch>
@@ -4143,7 +4155,13 @@
           <p:nvPr/>
         </p:nvPicPr>
         <p:blipFill>
-          <a:blip r:embed="rId4"/>
+          <a:blip r:embed="rId6">
+            <a:extLst>
+              <a:ext uri="{96DAC541-7B7A-43D3-8B79-37D633B846F1}">
+                <asvg:svgBlip xmlns:asvg="http://schemas.microsoft.com/office/drawing/2016/SVG/main" r:embed="rId7"/>
+              </a:ext>
+            </a:extLst>
+          </a:blip>
           <a:stretch>
             <a:fillRect/>
           </a:stretch>
@@ -4285,7 +4303,13 @@
           <p:nvPr/>
         </p:nvPicPr>
         <p:blipFill>
-          <a:blip r:embed="rId5"/>
+          <a:blip r:embed="rId8">
+            <a:extLst>
+              <a:ext uri="{96DAC541-7B7A-43D3-8B79-37D633B846F1}">
+                <asvg:svgBlip xmlns:asvg="http://schemas.microsoft.com/office/drawing/2016/SVG/main" r:embed="rId9"/>
+              </a:ext>
+            </a:extLst>
+          </a:blip>
           <a:stretch>
             <a:fillRect/>
           </a:stretch>
@@ -4427,7 +4451,13 @@
           <p:nvPr/>
         </p:nvPicPr>
         <p:blipFill>
-          <a:blip r:embed="rId6"/>
+          <a:blip r:embed="rId10">
+            <a:extLst>
+              <a:ext uri="{96DAC541-7B7A-43D3-8B79-37D633B846F1}">
+                <asvg:svgBlip xmlns:asvg="http://schemas.microsoft.com/office/drawing/2016/SVG/main" r:embed="rId11"/>
+              </a:ext>
+            </a:extLst>
+          </a:blip>
           <a:stretch>
             <a:fillRect/>
           </a:stretch>
@@ -4569,7 +4599,13 @@
           <p:nvPr/>
         </p:nvPicPr>
         <p:blipFill>
-          <a:blip r:embed="rId7"/>
+          <a:blip r:embed="rId12">
+            <a:extLst>
+              <a:ext uri="{96DAC541-7B7A-43D3-8B79-37D633B846F1}">
+                <asvg:svgBlip xmlns:asvg="http://schemas.microsoft.com/office/drawing/2016/SVG/main" r:embed="rId13"/>
+              </a:ext>
+            </a:extLst>
+          </a:blip>
           <a:stretch>
             <a:fillRect/>
           </a:stretch>
@@ -4711,7 +4747,13 @@
           <p:nvPr/>
         </p:nvPicPr>
         <p:blipFill>
-          <a:blip r:embed="rId8"/>
+          <a:blip r:embed="rId14">
+            <a:extLst>
+              <a:ext uri="{96DAC541-7B7A-43D3-8B79-37D633B846F1}">
+                <asvg:svgBlip xmlns:asvg="http://schemas.microsoft.com/office/drawing/2016/SVG/main" r:embed="rId15"/>
+              </a:ext>
+            </a:extLst>
+          </a:blip>
           <a:stretch>
             <a:fillRect/>
           </a:stretch>
@@ -4853,7 +4895,13 @@
           <p:nvPr/>
         </p:nvPicPr>
         <p:blipFill>
-          <a:blip r:embed="rId9"/>
+          <a:blip r:embed="rId16">
+            <a:extLst>
+              <a:ext uri="{96DAC541-7B7A-43D3-8B79-37D633B846F1}">
+                <asvg:svgBlip xmlns:asvg="http://schemas.microsoft.com/office/drawing/2016/SVG/main" r:embed="rId17"/>
+              </a:ext>
+            </a:extLst>
+          </a:blip>
           <a:stretch>
             <a:fillRect/>
           </a:stretch>
@@ -4995,7 +5043,13 @@
           <p:nvPr/>
         </p:nvPicPr>
         <p:blipFill>
-          <a:blip r:embed="rId10"/>
+          <a:blip r:embed="rId18">
+            <a:extLst>
+              <a:ext uri="{96DAC541-7B7A-43D3-8B79-37D633B846F1}">
+                <asvg:svgBlip xmlns:asvg="http://schemas.microsoft.com/office/drawing/2016/SVG/main" r:embed="rId19"/>
+              </a:ext>
+            </a:extLst>
+          </a:blip>
           <a:stretch>
             <a:fillRect/>
           </a:stretch>
@@ -5137,7 +5191,13 @@
           <p:nvPr/>
         </p:nvPicPr>
         <p:blipFill>
-          <a:blip r:embed="rId11"/>
+          <a:blip r:embed="rId20">
+            <a:extLst>
+              <a:ext uri="{96DAC541-7B7A-43D3-8B79-37D633B846F1}">
+                <asvg:svgBlip xmlns:asvg="http://schemas.microsoft.com/office/drawing/2016/SVG/main" r:embed="rId21"/>
+              </a:ext>
+            </a:extLst>
+          </a:blip>
           <a:stretch>
             <a:fillRect/>
           </a:stretch>
@@ -5279,7 +5339,13 @@
           <p:nvPr/>
         </p:nvPicPr>
         <p:blipFill>
-          <a:blip r:embed="rId12"/>
+          <a:blip r:embed="rId22">
+            <a:extLst>
+              <a:ext uri="{96DAC541-7B7A-43D3-8B79-37D633B846F1}">
+                <asvg:svgBlip xmlns:asvg="http://schemas.microsoft.com/office/drawing/2016/SVG/main" r:embed="rId23"/>
+              </a:ext>
+            </a:extLst>
+          </a:blip>
           <a:stretch>
             <a:fillRect/>
           </a:stretch>
@@ -5421,7 +5487,13 @@
           <p:nvPr/>
         </p:nvPicPr>
         <p:blipFill>
-          <a:blip r:embed="rId13"/>
+          <a:blip r:embed="rId24">
+            <a:extLst>
+              <a:ext uri="{96DAC541-7B7A-43D3-8B79-37D633B846F1}">
+                <asvg:svgBlip xmlns:asvg="http://schemas.microsoft.com/office/drawing/2016/SVG/main" r:embed="rId25"/>
+              </a:ext>
+            </a:extLst>
+          </a:blip>
           <a:stretch>
             <a:fillRect/>
           </a:stretch>
@@ -5635,7 +5707,7 @@
                 </a:solidFill>
                 <a:latin typeface="Microsoft YaHei"/>
               </a:rPr>
-              <a:t>色:深蓝灰   ·   一页 12 图</a:t>
+              <a:t>色:深蓝灰   ·   一页 12 图   ·   矢量</a:t>
             </a:r>
           </a:p>
         </p:txBody>
@@ -5697,7 +5769,13 @@
           <p:nvPr/>
         </p:nvPicPr>
         <p:blipFill>
-          <a:blip r:embed="rId2"/>
+          <a:blip r:embed="rId2">
+            <a:extLst>
+              <a:ext uri="{96DAC541-7B7A-43D3-8B79-37D633B846F1}">
+                <asvg:svgBlip xmlns:asvg="http://schemas.microsoft.com/office/drawing/2016/SVG/main" r:embed="rId3"/>
+              </a:ext>
+            </a:extLst>
+          </a:blip>
           <a:stretch>
             <a:fillRect/>
           </a:stretch>
@@ -5839,7 +5917,13 @@
           <p:nvPr/>
         </p:nvPicPr>
         <p:blipFill>
-          <a:blip r:embed="rId3"/>
+          <a:blip r:embed="rId4">
+            <a:extLst>
+              <a:ext uri="{96DAC541-7B7A-43D3-8B79-37D633B846F1}">
+                <asvg:svgBlip xmlns:asvg="http://schemas.microsoft.com/office/drawing/2016/SVG/main" r:embed="rId5"/>
+              </a:ext>
+            </a:extLst>
+          </a:blip>
           <a:stretch>
             <a:fillRect/>
           </a:stretch>
@@ -5981,7 +6065,13 @@
           <p:nvPr/>
         </p:nvPicPr>
         <p:blipFill>
-          <a:blip r:embed="rId4"/>
+          <a:blip r:embed="rId6">
+            <a:extLst>
+              <a:ext uri="{96DAC541-7B7A-43D3-8B79-37D633B846F1}">
+                <asvg:svgBlip xmlns:asvg="http://schemas.microsoft.com/office/drawing/2016/SVG/main" r:embed="rId7"/>
+              </a:ext>
+            </a:extLst>
+          </a:blip>
           <a:stretch>
             <a:fillRect/>
           </a:stretch>
@@ -6123,7 +6213,13 @@
           <p:nvPr/>
         </p:nvPicPr>
         <p:blipFill>
-          <a:blip r:embed="rId5"/>
+          <a:blip r:embed="rId8">
+            <a:extLst>
+              <a:ext uri="{96DAC541-7B7A-43D3-8B79-37D633B846F1}">
+                <asvg:svgBlip xmlns:asvg="http://schemas.microsoft.com/office/drawing/2016/SVG/main" r:embed="rId9"/>
+              </a:ext>
+            </a:extLst>
+          </a:blip>
           <a:stretch>
             <a:fillRect/>
           </a:stretch>
@@ -6265,7 +6361,13 @@
           <p:nvPr/>
         </p:nvPicPr>
         <p:blipFill>
-          <a:blip r:embed="rId6"/>
+          <a:blip r:embed="rId10">
+            <a:extLst>
+              <a:ext uri="{96DAC541-7B7A-43D3-8B79-37D633B846F1}">
+                <asvg:svgBlip xmlns:asvg="http://schemas.microsoft.com/office/drawing/2016/SVG/main" r:embed="rId11"/>
+              </a:ext>
+            </a:extLst>
+          </a:blip>
           <a:stretch>
             <a:fillRect/>
           </a:stretch>
@@ -6407,7 +6509,13 @@
           <p:nvPr/>
         </p:nvPicPr>
         <p:blipFill>
-          <a:blip r:embed="rId7"/>
+          <a:blip r:embed="rId12">
+            <a:extLst>
+              <a:ext uri="{96DAC541-7B7A-43D3-8B79-37D633B846F1}">
+                <asvg:svgBlip xmlns:asvg="http://schemas.microsoft.com/office/drawing/2016/SVG/main" r:embed="rId13"/>
+              </a:ext>
+            </a:extLst>
+          </a:blip>
           <a:stretch>
             <a:fillRect/>
           </a:stretch>
@@ -6549,7 +6657,13 @@
           <p:nvPr/>
         </p:nvPicPr>
         <p:blipFill>
-          <a:blip r:embed="rId8"/>
+          <a:blip r:embed="rId14">
+            <a:extLst>
+              <a:ext uri="{96DAC541-7B7A-43D3-8B79-37D633B846F1}">
+                <asvg:svgBlip xmlns:asvg="http://schemas.microsoft.com/office/drawing/2016/SVG/main" r:embed="rId15"/>
+              </a:ext>
+            </a:extLst>
+          </a:blip>
           <a:stretch>
             <a:fillRect/>
           </a:stretch>
@@ -6691,7 +6805,13 @@
           <p:nvPr/>
         </p:nvPicPr>
         <p:blipFill>
-          <a:blip r:embed="rId9"/>
+          <a:blip r:embed="rId16">
+            <a:extLst>
+              <a:ext uri="{96DAC541-7B7A-43D3-8B79-37D633B846F1}">
+                <asvg:svgBlip xmlns:asvg="http://schemas.microsoft.com/office/drawing/2016/SVG/main" r:embed="rId17"/>
+              </a:ext>
+            </a:extLst>
+          </a:blip>
           <a:stretch>
             <a:fillRect/>
           </a:stretch>
@@ -6833,7 +6953,13 @@
           <p:nvPr/>
         </p:nvPicPr>
         <p:blipFill>
-          <a:blip r:embed="rId10"/>
+          <a:blip r:embed="rId18">
+            <a:extLst>
+              <a:ext uri="{96DAC541-7B7A-43D3-8B79-37D633B846F1}">
+                <asvg:svgBlip xmlns:asvg="http://schemas.microsoft.com/office/drawing/2016/SVG/main" r:embed="rId19"/>
+              </a:ext>
+            </a:extLst>
+          </a:blip>
           <a:stretch>
             <a:fillRect/>
           </a:stretch>
@@ -6975,7 +7101,13 @@
           <p:nvPr/>
         </p:nvPicPr>
         <p:blipFill>
-          <a:blip r:embed="rId11"/>
+          <a:blip r:embed="rId20">
+            <a:extLst>
+              <a:ext uri="{96DAC541-7B7A-43D3-8B79-37D633B846F1}">
+                <asvg:svgBlip xmlns:asvg="http://schemas.microsoft.com/office/drawing/2016/SVG/main" r:embed="rId21"/>
+              </a:ext>
+            </a:extLst>
+          </a:blip>
           <a:stretch>
             <a:fillRect/>
           </a:stretch>
@@ -7154,7 +7286,7 @@
                 </a:solidFill>
                 <a:latin typeface="Microsoft YaHei"/>
               </a:rPr>
-              <a:t>三色对照 · 各组代表图标</a:t>
+              <a:t>三色对照 · 矢量 · 可在 PPT 中改色</a:t>
             </a:r>
           </a:p>
         </p:txBody>
@@ -7658,7 +7790,13 @@
           <p:nvPr/>
         </p:nvPicPr>
         <p:blipFill>
-          <a:blip r:embed="rId2"/>
+          <a:blip r:embed="rId2">
+            <a:extLst>
+              <a:ext uri="{96DAC541-7B7A-43D3-8B79-37D633B846F1}">
+                <asvg:svgBlip xmlns:asvg="http://schemas.microsoft.com/office/drawing/2016/SVG/main" r:embed="rId3"/>
+              </a:ext>
+            </a:extLst>
+          </a:blip>
           <a:stretch>
             <a:fillRect/>
           </a:stretch>
@@ -7730,7 +7868,13 @@
           <p:nvPr/>
         </p:nvPicPr>
         <p:blipFill>
-          <a:blip r:embed="rId3"/>
+          <a:blip r:embed="rId4">
+            <a:extLst>
+              <a:ext uri="{96DAC541-7B7A-43D3-8B79-37D633B846F1}">
+                <asvg:svgBlip xmlns:asvg="http://schemas.microsoft.com/office/drawing/2016/SVG/main" r:embed="rId5"/>
+              </a:ext>
+            </a:extLst>
+          </a:blip>
           <a:stretch>
             <a:fillRect/>
           </a:stretch>
@@ -7802,7 +7946,13 @@
           <p:nvPr/>
         </p:nvPicPr>
         <p:blipFill>
-          <a:blip r:embed="rId4"/>
+          <a:blip r:embed="rId6">
+            <a:extLst>
+              <a:ext uri="{96DAC541-7B7A-43D3-8B79-37D633B846F1}">
+                <asvg:svgBlip xmlns:asvg="http://schemas.microsoft.com/office/drawing/2016/SVG/main" r:embed="rId7"/>
+              </a:ext>
+            </a:extLst>
+          </a:blip>
           <a:stretch>
             <a:fillRect/>
           </a:stretch>
@@ -7992,7 +8142,13 @@
           <p:nvPr/>
         </p:nvPicPr>
         <p:blipFill>
-          <a:blip r:embed="rId5"/>
+          <a:blip r:embed="rId8">
+            <a:extLst>
+              <a:ext uri="{96DAC541-7B7A-43D3-8B79-37D633B846F1}">
+                <asvg:svgBlip xmlns:asvg="http://schemas.microsoft.com/office/drawing/2016/SVG/main" r:embed="rId9"/>
+              </a:ext>
+            </a:extLst>
+          </a:blip>
           <a:stretch>
             <a:fillRect/>
           </a:stretch>
@@ -8064,7 +8220,13 @@
           <p:nvPr/>
         </p:nvPicPr>
         <p:blipFill>
-          <a:blip r:embed="rId6"/>
+          <a:blip r:embed="rId10">
+            <a:extLst>
+              <a:ext uri="{96DAC541-7B7A-43D3-8B79-37D633B846F1}">
+                <asvg:svgBlip xmlns:asvg="http://schemas.microsoft.com/office/drawing/2016/SVG/main" r:embed="rId11"/>
+              </a:ext>
+            </a:extLst>
+          </a:blip>
           <a:stretch>
             <a:fillRect/>
           </a:stretch>
@@ -8136,7 +8298,13 @@
           <p:nvPr/>
         </p:nvPicPr>
         <p:blipFill>
-          <a:blip r:embed="rId7"/>
+          <a:blip r:embed="rId12">
+            <a:extLst>
+              <a:ext uri="{96DAC541-7B7A-43D3-8B79-37D633B846F1}">
+                <asvg:svgBlip xmlns:asvg="http://schemas.microsoft.com/office/drawing/2016/SVG/main" r:embed="rId13"/>
+              </a:ext>
+            </a:extLst>
+          </a:blip>
           <a:stretch>
             <a:fillRect/>
           </a:stretch>
@@ -8326,7 +8494,13 @@
           <p:nvPr/>
         </p:nvPicPr>
         <p:blipFill>
-          <a:blip r:embed="rId8"/>
+          <a:blip r:embed="rId14">
+            <a:extLst>
+              <a:ext uri="{96DAC541-7B7A-43D3-8B79-37D633B846F1}">
+                <asvg:svgBlip xmlns:asvg="http://schemas.microsoft.com/office/drawing/2016/SVG/main" r:embed="rId15"/>
+              </a:ext>
+            </a:extLst>
+          </a:blip>
           <a:stretch>
             <a:fillRect/>
           </a:stretch>
@@ -8398,7 +8572,13 @@
           <p:nvPr/>
         </p:nvPicPr>
         <p:blipFill>
-          <a:blip r:embed="rId9"/>
+          <a:blip r:embed="rId16">
+            <a:extLst>
+              <a:ext uri="{96DAC541-7B7A-43D3-8B79-37D633B846F1}">
+                <asvg:svgBlip xmlns:asvg="http://schemas.microsoft.com/office/drawing/2016/SVG/main" r:embed="rId17"/>
+              </a:ext>
+            </a:extLst>
+          </a:blip>
           <a:stretch>
             <a:fillRect/>
           </a:stretch>
@@ -8470,7 +8650,13 @@
           <p:nvPr/>
         </p:nvPicPr>
         <p:blipFill>
-          <a:blip r:embed="rId10"/>
+          <a:blip r:embed="rId18">
+            <a:extLst>
+              <a:ext uri="{96DAC541-7B7A-43D3-8B79-37D633B846F1}">
+                <asvg:svgBlip xmlns:asvg="http://schemas.microsoft.com/office/drawing/2016/SVG/main" r:embed="rId19"/>
+              </a:ext>
+            </a:extLst>
+          </a:blip>
           <a:stretch>
             <a:fillRect/>
           </a:stretch>
@@ -8660,7 +8846,13 @@
           <p:nvPr/>
         </p:nvPicPr>
         <p:blipFill>
-          <a:blip r:embed="rId11"/>
+          <a:blip r:embed="rId20">
+            <a:extLst>
+              <a:ext uri="{96DAC541-7B7A-43D3-8B79-37D633B846F1}">
+                <asvg:svgBlip xmlns:asvg="http://schemas.microsoft.com/office/drawing/2016/SVG/main" r:embed="rId21"/>
+              </a:ext>
+            </a:extLst>
+          </a:blip>
           <a:stretch>
             <a:fillRect/>
           </a:stretch>
@@ -8732,7 +8924,13 @@
           <p:nvPr/>
         </p:nvPicPr>
         <p:blipFill>
-          <a:blip r:embed="rId12"/>
+          <a:blip r:embed="rId22">
+            <a:extLst>
+              <a:ext uri="{96DAC541-7B7A-43D3-8B79-37D633B846F1}">
+                <asvg:svgBlip xmlns:asvg="http://schemas.microsoft.com/office/drawing/2016/SVG/main" r:embed="rId23"/>
+              </a:ext>
+            </a:extLst>
+          </a:blip>
           <a:stretch>
             <a:fillRect/>
           </a:stretch>
@@ -8804,7 +9002,13 @@
           <p:nvPr/>
         </p:nvPicPr>
         <p:blipFill>
-          <a:blip r:embed="rId13"/>
+          <a:blip r:embed="rId24">
+            <a:extLst>
+              <a:ext uri="{96DAC541-7B7A-43D3-8B79-37D633B846F1}">
+                <asvg:svgBlip xmlns:asvg="http://schemas.microsoft.com/office/drawing/2016/SVG/main" r:embed="rId25"/>
+              </a:ext>
+            </a:extLst>
+          </a:blip>
           <a:stretch>
             <a:fillRect/>
           </a:stretch>
@@ -8994,7 +9198,13 @@
           <p:nvPr/>
         </p:nvPicPr>
         <p:blipFill>
-          <a:blip r:embed="rId14"/>
+          <a:blip r:embed="rId26">
+            <a:extLst>
+              <a:ext uri="{96DAC541-7B7A-43D3-8B79-37D633B846F1}">
+                <asvg:svgBlip xmlns:asvg="http://schemas.microsoft.com/office/drawing/2016/SVG/main" r:embed="rId27"/>
+              </a:ext>
+            </a:extLst>
+          </a:blip>
           <a:stretch>
             <a:fillRect/>
           </a:stretch>
@@ -9066,7 +9276,13 @@
           <p:nvPr/>
         </p:nvPicPr>
         <p:blipFill>
-          <a:blip r:embed="rId15"/>
+          <a:blip r:embed="rId28">
+            <a:extLst>
+              <a:ext uri="{96DAC541-7B7A-43D3-8B79-37D633B846F1}">
+                <asvg:svgBlip xmlns:asvg="http://schemas.microsoft.com/office/drawing/2016/SVG/main" r:embed="rId29"/>
+              </a:ext>
+            </a:extLst>
+          </a:blip>
           <a:stretch>
             <a:fillRect/>
           </a:stretch>
@@ -9138,7 +9354,13 @@
           <p:nvPr/>
         </p:nvPicPr>
         <p:blipFill>
-          <a:blip r:embed="rId16"/>
+          <a:blip r:embed="rId30">
+            <a:extLst>
+              <a:ext uri="{96DAC541-7B7A-43D3-8B79-37D633B846F1}">
+                <asvg:svgBlip xmlns:asvg="http://schemas.microsoft.com/office/drawing/2016/SVG/main" r:embed="rId31"/>
+              </a:ext>
+            </a:extLst>
+          </a:blip>
           <a:stretch>
             <a:fillRect/>
           </a:stretch>
@@ -9328,7 +9550,13 @@
           <p:nvPr/>
         </p:nvPicPr>
         <p:blipFill>
-          <a:blip r:embed="rId17"/>
+          <a:blip r:embed="rId32">
+            <a:extLst>
+              <a:ext uri="{96DAC541-7B7A-43D3-8B79-37D633B846F1}">
+                <asvg:svgBlip xmlns:asvg="http://schemas.microsoft.com/office/drawing/2016/SVG/main" r:embed="rId33"/>
+              </a:ext>
+            </a:extLst>
+          </a:blip>
           <a:stretch>
             <a:fillRect/>
           </a:stretch>
@@ -9400,7 +9628,13 @@
           <p:nvPr/>
         </p:nvPicPr>
         <p:blipFill>
-          <a:blip r:embed="rId18"/>
+          <a:blip r:embed="rId34">
+            <a:extLst>
+              <a:ext uri="{96DAC541-7B7A-43D3-8B79-37D633B846F1}">
+                <asvg:svgBlip xmlns:asvg="http://schemas.microsoft.com/office/drawing/2016/SVG/main" r:embed="rId35"/>
+              </a:ext>
+            </a:extLst>
+          </a:blip>
           <a:stretch>
             <a:fillRect/>
           </a:stretch>
@@ -9472,7 +9706,13 @@
           <p:nvPr/>
         </p:nvPicPr>
         <p:blipFill>
-          <a:blip r:embed="rId19"/>
+          <a:blip r:embed="rId36">
+            <a:extLst>
+              <a:ext uri="{96DAC541-7B7A-43D3-8B79-37D633B846F1}">
+                <asvg:svgBlip xmlns:asvg="http://schemas.microsoft.com/office/drawing/2016/SVG/main" r:embed="rId37"/>
+              </a:ext>
+            </a:extLst>
+          </a:blip>
           <a:stretch>
             <a:fillRect/>
           </a:stretch>
@@ -9662,7 +9902,13 @@
           <p:nvPr/>
         </p:nvPicPr>
         <p:blipFill>
-          <a:blip r:embed="rId20"/>
+          <a:blip r:embed="rId38">
+            <a:extLst>
+              <a:ext uri="{96DAC541-7B7A-43D3-8B79-37D633B846F1}">
+                <asvg:svgBlip xmlns:asvg="http://schemas.microsoft.com/office/drawing/2016/SVG/main" r:embed="rId39"/>
+              </a:ext>
+            </a:extLst>
+          </a:blip>
           <a:stretch>
             <a:fillRect/>
           </a:stretch>
@@ -9734,7 +9980,13 @@
           <p:nvPr/>
         </p:nvPicPr>
         <p:blipFill>
-          <a:blip r:embed="rId21"/>
+          <a:blip r:embed="rId40">
+            <a:extLst>
+              <a:ext uri="{96DAC541-7B7A-43D3-8B79-37D633B846F1}">
+                <asvg:svgBlip xmlns:asvg="http://schemas.microsoft.com/office/drawing/2016/SVG/main" r:embed="rId41"/>
+              </a:ext>
+            </a:extLst>
+          </a:blip>
           <a:stretch>
             <a:fillRect/>
           </a:stretch>
@@ -9806,7 +10058,13 @@
           <p:nvPr/>
         </p:nvPicPr>
         <p:blipFill>
-          <a:blip r:embed="rId22"/>
+          <a:blip r:embed="rId42">
+            <a:extLst>
+              <a:ext uri="{96DAC541-7B7A-43D3-8B79-37D633B846F1}">
+                <asvg:svgBlip xmlns:asvg="http://schemas.microsoft.com/office/drawing/2016/SVG/main" r:embed="rId43"/>
+              </a:ext>
+            </a:extLst>
+          </a:blip>
           <a:stretch>
             <a:fillRect/>
           </a:stretch>
@@ -9996,7 +10254,13 @@
           <p:nvPr/>
         </p:nvPicPr>
         <p:blipFill>
-          <a:blip r:embed="rId23"/>
+          <a:blip r:embed="rId44">
+            <a:extLst>
+              <a:ext uri="{96DAC541-7B7A-43D3-8B79-37D633B846F1}">
+                <asvg:svgBlip xmlns:asvg="http://schemas.microsoft.com/office/drawing/2016/SVG/main" r:embed="rId45"/>
+              </a:ext>
+            </a:extLst>
+          </a:blip>
           <a:stretch>
             <a:fillRect/>
           </a:stretch>
@@ -10068,7 +10332,13 @@
           <p:nvPr/>
         </p:nvPicPr>
         <p:blipFill>
-          <a:blip r:embed="rId24"/>
+          <a:blip r:embed="rId46">
+            <a:extLst>
+              <a:ext uri="{96DAC541-7B7A-43D3-8B79-37D633B846F1}">
+                <asvg:svgBlip xmlns:asvg="http://schemas.microsoft.com/office/drawing/2016/SVG/main" r:embed="rId47"/>
+              </a:ext>
+            </a:extLst>
+          </a:blip>
           <a:stretch>
             <a:fillRect/>
           </a:stretch>
@@ -10140,7 +10410,13 @@
           <p:nvPr/>
         </p:nvPicPr>
         <p:blipFill>
-          <a:blip r:embed="rId25"/>
+          <a:blip r:embed="rId48">
+            <a:extLst>
+              <a:ext uri="{96DAC541-7B7A-43D3-8B79-37D633B846F1}">
+                <asvg:svgBlip xmlns:asvg="http://schemas.microsoft.com/office/drawing/2016/SVG/main" r:embed="rId49"/>
+              </a:ext>
+            </a:extLst>
+          </a:blip>
           <a:stretch>
             <a:fillRect/>
           </a:stretch>
@@ -10284,7 +10560,7 @@
                 </a:solidFill>
                 <a:latin typeface="Microsoft YaHei"/>
               </a:rPr>
-              <a:t>色:深蓝灰   ·   一页 12 图</a:t>
+              <a:t>色:深蓝灰   ·   一页 12 图   ·   矢量</a:t>
             </a:r>
           </a:p>
         </p:txBody>
@@ -10346,7 +10622,13 @@
           <p:nvPr/>
         </p:nvPicPr>
         <p:blipFill>
-          <a:blip r:embed="rId2"/>
+          <a:blip r:embed="rId2">
+            <a:extLst>
+              <a:ext uri="{96DAC541-7B7A-43D3-8B79-37D633B846F1}">
+                <asvg:svgBlip xmlns:asvg="http://schemas.microsoft.com/office/drawing/2016/SVG/main" r:embed="rId3"/>
+              </a:ext>
+            </a:extLst>
+          </a:blip>
           <a:stretch>
             <a:fillRect/>
           </a:stretch>
@@ -10488,7 +10770,13 @@
           <p:nvPr/>
         </p:nvPicPr>
         <p:blipFill>
-          <a:blip r:embed="rId3"/>
+          <a:blip r:embed="rId4">
+            <a:extLst>
+              <a:ext uri="{96DAC541-7B7A-43D3-8B79-37D633B846F1}">
+                <asvg:svgBlip xmlns:asvg="http://schemas.microsoft.com/office/drawing/2016/SVG/main" r:embed="rId5"/>
+              </a:ext>
+            </a:extLst>
+          </a:blip>
           <a:stretch>
             <a:fillRect/>
           </a:stretch>
@@ -10630,7 +10918,13 @@
           <p:nvPr/>
         </p:nvPicPr>
         <p:blipFill>
-          <a:blip r:embed="rId4"/>
+          <a:blip r:embed="rId6">
+            <a:extLst>
+              <a:ext uri="{96DAC541-7B7A-43D3-8B79-37D633B846F1}">
+                <asvg:svgBlip xmlns:asvg="http://schemas.microsoft.com/office/drawing/2016/SVG/main" r:embed="rId7"/>
+              </a:ext>
+            </a:extLst>
+          </a:blip>
           <a:stretch>
             <a:fillRect/>
           </a:stretch>
@@ -10772,7 +11066,13 @@
           <p:nvPr/>
         </p:nvPicPr>
         <p:blipFill>
-          <a:blip r:embed="rId5"/>
+          <a:blip r:embed="rId8">
+            <a:extLst>
+              <a:ext uri="{96DAC541-7B7A-43D3-8B79-37D633B846F1}">
+                <asvg:svgBlip xmlns:asvg="http://schemas.microsoft.com/office/drawing/2016/SVG/main" r:embed="rId9"/>
+              </a:ext>
+            </a:extLst>
+          </a:blip>
           <a:stretch>
             <a:fillRect/>
           </a:stretch>
@@ -10914,7 +11214,13 @@
           <p:nvPr/>
         </p:nvPicPr>
         <p:blipFill>
-          <a:blip r:embed="rId6"/>
+          <a:blip r:embed="rId10">
+            <a:extLst>
+              <a:ext uri="{96DAC541-7B7A-43D3-8B79-37D633B846F1}">
+                <asvg:svgBlip xmlns:asvg="http://schemas.microsoft.com/office/drawing/2016/SVG/main" r:embed="rId11"/>
+              </a:ext>
+            </a:extLst>
+          </a:blip>
           <a:stretch>
             <a:fillRect/>
           </a:stretch>
@@ -11056,7 +11362,13 @@
           <p:nvPr/>
         </p:nvPicPr>
         <p:blipFill>
-          <a:blip r:embed="rId7"/>
+          <a:blip r:embed="rId12">
+            <a:extLst>
+              <a:ext uri="{96DAC541-7B7A-43D3-8B79-37D633B846F1}">
+                <asvg:svgBlip xmlns:asvg="http://schemas.microsoft.com/office/drawing/2016/SVG/main" r:embed="rId13"/>
+              </a:ext>
+            </a:extLst>
+          </a:blip>
           <a:stretch>
             <a:fillRect/>
           </a:stretch>
@@ -11198,7 +11510,13 @@
           <p:nvPr/>
         </p:nvPicPr>
         <p:blipFill>
-          <a:blip r:embed="rId8"/>
+          <a:blip r:embed="rId14">
+            <a:extLst>
+              <a:ext uri="{96DAC541-7B7A-43D3-8B79-37D633B846F1}">
+                <asvg:svgBlip xmlns:asvg="http://schemas.microsoft.com/office/drawing/2016/SVG/main" r:embed="rId15"/>
+              </a:ext>
+            </a:extLst>
+          </a:blip>
           <a:stretch>
             <a:fillRect/>
           </a:stretch>
@@ -11340,7 +11658,13 @@
           <p:nvPr/>
         </p:nvPicPr>
         <p:blipFill>
-          <a:blip r:embed="rId9"/>
+          <a:blip r:embed="rId16">
+            <a:extLst>
+              <a:ext uri="{96DAC541-7B7A-43D3-8B79-37D633B846F1}">
+                <asvg:svgBlip xmlns:asvg="http://schemas.microsoft.com/office/drawing/2016/SVG/main" r:embed="rId17"/>
+              </a:ext>
+            </a:extLst>
+          </a:blip>
           <a:stretch>
             <a:fillRect/>
           </a:stretch>
@@ -11482,7 +11806,13 @@
           <p:nvPr/>
         </p:nvPicPr>
         <p:blipFill>
-          <a:blip r:embed="rId10"/>
+          <a:blip r:embed="rId18">
+            <a:extLst>
+              <a:ext uri="{96DAC541-7B7A-43D3-8B79-37D633B846F1}">
+                <asvg:svgBlip xmlns:asvg="http://schemas.microsoft.com/office/drawing/2016/SVG/main" r:embed="rId19"/>
+              </a:ext>
+            </a:extLst>
+          </a:blip>
           <a:stretch>
             <a:fillRect/>
           </a:stretch>
@@ -11624,7 +11954,13 @@
           <p:nvPr/>
         </p:nvPicPr>
         <p:blipFill>
-          <a:blip r:embed="rId11"/>
+          <a:blip r:embed="rId20">
+            <a:extLst>
+              <a:ext uri="{96DAC541-7B7A-43D3-8B79-37D633B846F1}">
+                <asvg:svgBlip xmlns:asvg="http://schemas.microsoft.com/office/drawing/2016/SVG/main" r:embed="rId21"/>
+              </a:ext>
+            </a:extLst>
+          </a:blip>
           <a:stretch>
             <a:fillRect/>
           </a:stretch>
@@ -11766,7 +12102,13 @@
           <p:nvPr/>
         </p:nvPicPr>
         <p:blipFill>
-          <a:blip r:embed="rId12"/>
+          <a:blip r:embed="rId22">
+            <a:extLst>
+              <a:ext uri="{96DAC541-7B7A-43D3-8B79-37D633B846F1}">
+                <asvg:svgBlip xmlns:asvg="http://schemas.microsoft.com/office/drawing/2016/SVG/main" r:embed="rId23"/>
+              </a:ext>
+            </a:extLst>
+          </a:blip>
           <a:stretch>
             <a:fillRect/>
           </a:stretch>
@@ -11908,7 +12250,13 @@
           <p:nvPr/>
         </p:nvPicPr>
         <p:blipFill>
-          <a:blip r:embed="rId13"/>
+          <a:blip r:embed="rId24">
+            <a:extLst>
+              <a:ext uri="{96DAC541-7B7A-43D3-8B79-37D633B846F1}">
+                <asvg:svgBlip xmlns:asvg="http://schemas.microsoft.com/office/drawing/2016/SVG/main" r:embed="rId25"/>
+              </a:ext>
+            </a:extLst>
+          </a:blip>
           <a:stretch>
             <a:fillRect/>
           </a:stretch>
@@ -12122,7 +12470,7 @@
                 </a:solidFill>
                 <a:latin typeface="Microsoft YaHei"/>
               </a:rPr>
-              <a:t>色:深蓝灰   ·   一页 12 图</a:t>
+              <a:t>色:深蓝灰   ·   一页 12 图   ·   矢量</a:t>
             </a:r>
           </a:p>
         </p:txBody>
@@ -12184,7 +12532,13 @@
           <p:nvPr/>
         </p:nvPicPr>
         <p:blipFill>
-          <a:blip r:embed="rId2"/>
+          <a:blip r:embed="rId2">
+            <a:extLst>
+              <a:ext uri="{96DAC541-7B7A-43D3-8B79-37D633B846F1}">
+                <asvg:svgBlip xmlns:asvg="http://schemas.microsoft.com/office/drawing/2016/SVG/main" r:embed="rId3"/>
+              </a:ext>
+            </a:extLst>
+          </a:blip>
           <a:stretch>
             <a:fillRect/>
           </a:stretch>
@@ -12326,7 +12680,13 @@
           <p:nvPr/>
         </p:nvPicPr>
         <p:blipFill>
-          <a:blip r:embed="rId3"/>
+          <a:blip r:embed="rId4">
+            <a:extLst>
+              <a:ext uri="{96DAC541-7B7A-43D3-8B79-37D633B846F1}">
+                <asvg:svgBlip xmlns:asvg="http://schemas.microsoft.com/office/drawing/2016/SVG/main" r:embed="rId5"/>
+              </a:ext>
+            </a:extLst>
+          </a:blip>
           <a:stretch>
             <a:fillRect/>
           </a:stretch>
@@ -12468,7 +12828,13 @@
           <p:nvPr/>
         </p:nvPicPr>
         <p:blipFill>
-          <a:blip r:embed="rId4"/>
+          <a:blip r:embed="rId6">
+            <a:extLst>
+              <a:ext uri="{96DAC541-7B7A-43D3-8B79-37D633B846F1}">
+                <asvg:svgBlip xmlns:asvg="http://schemas.microsoft.com/office/drawing/2016/SVG/main" r:embed="rId7"/>
+              </a:ext>
+            </a:extLst>
+          </a:blip>
           <a:stretch>
             <a:fillRect/>
           </a:stretch>
@@ -12682,7 +13048,7 @@
                 </a:solidFill>
                 <a:latin typeface="Microsoft YaHei"/>
               </a:rPr>
-              <a:t>色:深蓝灰   ·   一页 12 图</a:t>
+              <a:t>色:深蓝灰   ·   一页 12 图   ·   矢量</a:t>
             </a:r>
           </a:p>
         </p:txBody>
@@ -12744,7 +13110,13 @@
           <p:nvPr/>
         </p:nvPicPr>
         <p:blipFill>
-          <a:blip r:embed="rId2"/>
+          <a:blip r:embed="rId2">
+            <a:extLst>
+              <a:ext uri="{96DAC541-7B7A-43D3-8B79-37D633B846F1}">
+                <asvg:svgBlip xmlns:asvg="http://schemas.microsoft.com/office/drawing/2016/SVG/main" r:embed="rId3"/>
+              </a:ext>
+            </a:extLst>
+          </a:blip>
           <a:stretch>
             <a:fillRect/>
           </a:stretch>
@@ -12886,7 +13258,13 @@
           <p:nvPr/>
         </p:nvPicPr>
         <p:blipFill>
-          <a:blip r:embed="rId3"/>
+          <a:blip r:embed="rId4">
+            <a:extLst>
+              <a:ext uri="{96DAC541-7B7A-43D3-8B79-37D633B846F1}">
+                <asvg:svgBlip xmlns:asvg="http://schemas.microsoft.com/office/drawing/2016/SVG/main" r:embed="rId5"/>
+              </a:ext>
+            </a:extLst>
+          </a:blip>
           <a:stretch>
             <a:fillRect/>
           </a:stretch>
@@ -13028,7 +13406,13 @@
           <p:nvPr/>
         </p:nvPicPr>
         <p:blipFill>
-          <a:blip r:embed="rId4"/>
+          <a:blip r:embed="rId6">
+            <a:extLst>
+              <a:ext uri="{96DAC541-7B7A-43D3-8B79-37D633B846F1}">
+                <asvg:svgBlip xmlns:asvg="http://schemas.microsoft.com/office/drawing/2016/SVG/main" r:embed="rId7"/>
+              </a:ext>
+            </a:extLst>
+          </a:blip>
           <a:stretch>
             <a:fillRect/>
           </a:stretch>
@@ -13170,7 +13554,13 @@
           <p:nvPr/>
         </p:nvPicPr>
         <p:blipFill>
-          <a:blip r:embed="rId5"/>
+          <a:blip r:embed="rId8">
+            <a:extLst>
+              <a:ext uri="{96DAC541-7B7A-43D3-8B79-37D633B846F1}">
+                <asvg:svgBlip xmlns:asvg="http://schemas.microsoft.com/office/drawing/2016/SVG/main" r:embed="rId9"/>
+              </a:ext>
+            </a:extLst>
+          </a:blip>
           <a:stretch>
             <a:fillRect/>
           </a:stretch>
@@ -13312,7 +13702,13 @@
           <p:nvPr/>
         </p:nvPicPr>
         <p:blipFill>
-          <a:blip r:embed="rId6"/>
+          <a:blip r:embed="rId10">
+            <a:extLst>
+              <a:ext uri="{96DAC541-7B7A-43D3-8B79-37D633B846F1}">
+                <asvg:svgBlip xmlns:asvg="http://schemas.microsoft.com/office/drawing/2016/SVG/main" r:embed="rId11"/>
+              </a:ext>
+            </a:extLst>
+          </a:blip>
           <a:stretch>
             <a:fillRect/>
           </a:stretch>
@@ -13454,7 +13850,13 @@
           <p:nvPr/>
         </p:nvPicPr>
         <p:blipFill>
-          <a:blip r:embed="rId7"/>
+          <a:blip r:embed="rId12">
+            <a:extLst>
+              <a:ext uri="{96DAC541-7B7A-43D3-8B79-37D633B846F1}">
+                <asvg:svgBlip xmlns:asvg="http://schemas.microsoft.com/office/drawing/2016/SVG/main" r:embed="rId13"/>
+              </a:ext>
+            </a:extLst>
+          </a:blip>
           <a:stretch>
             <a:fillRect/>
           </a:stretch>
@@ -13596,7 +13998,13 @@
           <p:nvPr/>
         </p:nvPicPr>
         <p:blipFill>
-          <a:blip r:embed="rId8"/>
+          <a:blip r:embed="rId14">
+            <a:extLst>
+              <a:ext uri="{96DAC541-7B7A-43D3-8B79-37D633B846F1}">
+                <asvg:svgBlip xmlns:asvg="http://schemas.microsoft.com/office/drawing/2016/SVG/main" r:embed="rId15"/>
+              </a:ext>
+            </a:extLst>
+          </a:blip>
           <a:stretch>
             <a:fillRect/>
           </a:stretch>
@@ -13738,7 +14146,13 @@
           <p:nvPr/>
         </p:nvPicPr>
         <p:blipFill>
-          <a:blip r:embed="rId9"/>
+          <a:blip r:embed="rId16">
+            <a:extLst>
+              <a:ext uri="{96DAC541-7B7A-43D3-8B79-37D633B846F1}">
+                <asvg:svgBlip xmlns:asvg="http://schemas.microsoft.com/office/drawing/2016/SVG/main" r:embed="rId17"/>
+              </a:ext>
+            </a:extLst>
+          </a:blip>
           <a:stretch>
             <a:fillRect/>
           </a:stretch>
@@ -13880,7 +14294,13 @@
           <p:nvPr/>
         </p:nvPicPr>
         <p:blipFill>
-          <a:blip r:embed="rId10"/>
+          <a:blip r:embed="rId18">
+            <a:extLst>
+              <a:ext uri="{96DAC541-7B7A-43D3-8B79-37D633B846F1}">
+                <asvg:svgBlip xmlns:asvg="http://schemas.microsoft.com/office/drawing/2016/SVG/main" r:embed="rId19"/>
+              </a:ext>
+            </a:extLst>
+          </a:blip>
           <a:stretch>
             <a:fillRect/>
           </a:stretch>
@@ -14022,7 +14442,13 @@
           <p:nvPr/>
         </p:nvPicPr>
         <p:blipFill>
-          <a:blip r:embed="rId11"/>
+          <a:blip r:embed="rId20">
+            <a:extLst>
+              <a:ext uri="{96DAC541-7B7A-43D3-8B79-37D633B846F1}">
+                <asvg:svgBlip xmlns:asvg="http://schemas.microsoft.com/office/drawing/2016/SVG/main" r:embed="rId21"/>
+              </a:ext>
+            </a:extLst>
+          </a:blip>
           <a:stretch>
             <a:fillRect/>
           </a:stretch>
@@ -14164,7 +14590,13 @@
           <p:nvPr/>
         </p:nvPicPr>
         <p:blipFill>
-          <a:blip r:embed="rId12"/>
+          <a:blip r:embed="rId22">
+            <a:extLst>
+              <a:ext uri="{96DAC541-7B7A-43D3-8B79-37D633B846F1}">
+                <asvg:svgBlip xmlns:asvg="http://schemas.microsoft.com/office/drawing/2016/SVG/main" r:embed="rId23"/>
+              </a:ext>
+            </a:extLst>
+          </a:blip>
           <a:stretch>
             <a:fillRect/>
           </a:stretch>
@@ -14306,7 +14738,13 @@
           <p:nvPr/>
         </p:nvPicPr>
         <p:blipFill>
-          <a:blip r:embed="rId13"/>
+          <a:blip r:embed="rId24">
+            <a:extLst>
+              <a:ext uri="{96DAC541-7B7A-43D3-8B79-37D633B846F1}">
+                <asvg:svgBlip xmlns:asvg="http://schemas.microsoft.com/office/drawing/2016/SVG/main" r:embed="rId25"/>
+              </a:ext>
+            </a:extLst>
+          </a:blip>
           <a:stretch>
             <a:fillRect/>
           </a:stretch>
@@ -14520,7 +14958,7 @@
                 </a:solidFill>
                 <a:latin typeface="Microsoft YaHei"/>
               </a:rPr>
-              <a:t>色:深蓝灰   ·   一页 12 图</a:t>
+              <a:t>色:深蓝灰   ·   一页 12 图   ·   矢量</a:t>
             </a:r>
           </a:p>
         </p:txBody>
@@ -14582,7 +15020,13 @@
           <p:nvPr/>
         </p:nvPicPr>
         <p:blipFill>
-          <a:blip r:embed="rId2"/>
+          <a:blip r:embed="rId2">
+            <a:extLst>
+              <a:ext uri="{96DAC541-7B7A-43D3-8B79-37D633B846F1}">
+                <asvg:svgBlip xmlns:asvg="http://schemas.microsoft.com/office/drawing/2016/SVG/main" r:embed="rId3"/>
+              </a:ext>
+            </a:extLst>
+          </a:blip>
           <a:stretch>
             <a:fillRect/>
           </a:stretch>
@@ -14724,7 +15168,13 @@
           <p:nvPr/>
         </p:nvPicPr>
         <p:blipFill>
-          <a:blip r:embed="rId3"/>
+          <a:blip r:embed="rId4">
+            <a:extLst>
+              <a:ext uri="{96DAC541-7B7A-43D3-8B79-37D633B846F1}">
+                <asvg:svgBlip xmlns:asvg="http://schemas.microsoft.com/office/drawing/2016/SVG/main" r:embed="rId5"/>
+              </a:ext>
+            </a:extLst>
+          </a:blip>
           <a:stretch>
             <a:fillRect/>
           </a:stretch>
@@ -14866,7 +15316,13 @@
           <p:nvPr/>
         </p:nvPicPr>
         <p:blipFill>
-          <a:blip r:embed="rId4"/>
+          <a:blip r:embed="rId6">
+            <a:extLst>
+              <a:ext uri="{96DAC541-7B7A-43D3-8B79-37D633B846F1}">
+                <asvg:svgBlip xmlns:asvg="http://schemas.microsoft.com/office/drawing/2016/SVG/main" r:embed="rId7"/>
+              </a:ext>
+            </a:extLst>
+          </a:blip>
           <a:stretch>
             <a:fillRect/>
           </a:stretch>
@@ -15008,7 +15464,13 @@
           <p:nvPr/>
         </p:nvPicPr>
         <p:blipFill>
-          <a:blip r:embed="rId5"/>
+          <a:blip r:embed="rId8">
+            <a:extLst>
+              <a:ext uri="{96DAC541-7B7A-43D3-8B79-37D633B846F1}">
+                <asvg:svgBlip xmlns:asvg="http://schemas.microsoft.com/office/drawing/2016/SVG/main" r:embed="rId9"/>
+              </a:ext>
+            </a:extLst>
+          </a:blip>
           <a:stretch>
             <a:fillRect/>
           </a:stretch>
@@ -15150,7 +15612,13 @@
           <p:nvPr/>
         </p:nvPicPr>
         <p:blipFill>
-          <a:blip r:embed="rId6"/>
+          <a:blip r:embed="rId10">
+            <a:extLst>
+              <a:ext uri="{96DAC541-7B7A-43D3-8B79-37D633B846F1}">
+                <asvg:svgBlip xmlns:asvg="http://schemas.microsoft.com/office/drawing/2016/SVG/main" r:embed="rId11"/>
+              </a:ext>
+            </a:extLst>
+          </a:blip>
           <a:stretch>
             <a:fillRect/>
           </a:stretch>
@@ -15292,7 +15760,13 @@
           <p:nvPr/>
         </p:nvPicPr>
         <p:blipFill>
-          <a:blip r:embed="rId7"/>
+          <a:blip r:embed="rId12">
+            <a:extLst>
+              <a:ext uri="{96DAC541-7B7A-43D3-8B79-37D633B846F1}">
+                <asvg:svgBlip xmlns:asvg="http://schemas.microsoft.com/office/drawing/2016/SVG/main" r:embed="rId13"/>
+              </a:ext>
+            </a:extLst>
+          </a:blip>
           <a:stretch>
             <a:fillRect/>
           </a:stretch>
@@ -15434,7 +15908,13 @@
           <p:nvPr/>
         </p:nvPicPr>
         <p:blipFill>
-          <a:blip r:embed="rId8"/>
+          <a:blip r:embed="rId14">
+            <a:extLst>
+              <a:ext uri="{96DAC541-7B7A-43D3-8B79-37D633B846F1}">
+                <asvg:svgBlip xmlns:asvg="http://schemas.microsoft.com/office/drawing/2016/SVG/main" r:embed="rId15"/>
+              </a:ext>
+            </a:extLst>
+          </a:blip>
           <a:stretch>
             <a:fillRect/>
           </a:stretch>
@@ -15576,7 +16056,13 @@
           <p:nvPr/>
         </p:nvPicPr>
         <p:blipFill>
-          <a:blip r:embed="rId9"/>
+          <a:blip r:embed="rId16">
+            <a:extLst>
+              <a:ext uri="{96DAC541-7B7A-43D3-8B79-37D633B846F1}">
+                <asvg:svgBlip xmlns:asvg="http://schemas.microsoft.com/office/drawing/2016/SVG/main" r:embed="rId17"/>
+              </a:ext>
+            </a:extLst>
+          </a:blip>
           <a:stretch>
             <a:fillRect/>
           </a:stretch>
@@ -15718,7 +16204,13 @@
           <p:nvPr/>
         </p:nvPicPr>
         <p:blipFill>
-          <a:blip r:embed="rId10"/>
+          <a:blip r:embed="rId18">
+            <a:extLst>
+              <a:ext uri="{96DAC541-7B7A-43D3-8B79-37D633B846F1}">
+                <asvg:svgBlip xmlns:asvg="http://schemas.microsoft.com/office/drawing/2016/SVG/main" r:embed="rId19"/>
+              </a:ext>
+            </a:extLst>
+          </a:blip>
           <a:stretch>
             <a:fillRect/>
           </a:stretch>
@@ -15860,7 +16352,13 @@
           <p:nvPr/>
         </p:nvPicPr>
         <p:blipFill>
-          <a:blip r:embed="rId11"/>
+          <a:blip r:embed="rId20">
+            <a:extLst>
+              <a:ext uri="{96DAC541-7B7A-43D3-8B79-37D633B846F1}">
+                <asvg:svgBlip xmlns:asvg="http://schemas.microsoft.com/office/drawing/2016/SVG/main" r:embed="rId21"/>
+              </a:ext>
+            </a:extLst>
+          </a:blip>
           <a:stretch>
             <a:fillRect/>
           </a:stretch>
@@ -16002,7 +16500,13 @@
           <p:nvPr/>
         </p:nvPicPr>
         <p:blipFill>
-          <a:blip r:embed="rId12"/>
+          <a:blip r:embed="rId22">
+            <a:extLst>
+              <a:ext uri="{96DAC541-7B7A-43D3-8B79-37D633B846F1}">
+                <asvg:svgBlip xmlns:asvg="http://schemas.microsoft.com/office/drawing/2016/SVG/main" r:embed="rId23"/>
+              </a:ext>
+            </a:extLst>
+          </a:blip>
           <a:stretch>
             <a:fillRect/>
           </a:stretch>
@@ -16144,7 +16648,13 @@
           <p:nvPr/>
         </p:nvPicPr>
         <p:blipFill>
-          <a:blip r:embed="rId13"/>
+          <a:blip r:embed="rId24">
+            <a:extLst>
+              <a:ext uri="{96DAC541-7B7A-43D3-8B79-37D633B846F1}">
+                <asvg:svgBlip xmlns:asvg="http://schemas.microsoft.com/office/drawing/2016/SVG/main" r:embed="rId25"/>
+              </a:ext>
+            </a:extLst>
+          </a:blip>
           <a:stretch>
             <a:fillRect/>
           </a:stretch>
@@ -16358,7 +16868,7 @@
                 </a:solidFill>
                 <a:latin typeface="Microsoft YaHei"/>
               </a:rPr>
-              <a:t>色:深蓝灰   ·   一页 12 图</a:t>
+              <a:t>色:深蓝灰   ·   一页 12 图   ·   矢量</a:t>
             </a:r>
           </a:p>
         </p:txBody>
@@ -16420,7 +16930,13 @@
           <p:nvPr/>
         </p:nvPicPr>
         <p:blipFill>
-          <a:blip r:embed="rId2"/>
+          <a:blip r:embed="rId2">
+            <a:extLst>
+              <a:ext uri="{96DAC541-7B7A-43D3-8B79-37D633B846F1}">
+                <asvg:svgBlip xmlns:asvg="http://schemas.microsoft.com/office/drawing/2016/SVG/main" r:embed="rId3"/>
+              </a:ext>
+            </a:extLst>
+          </a:blip>
           <a:stretch>
             <a:fillRect/>
           </a:stretch>
@@ -16562,7 +17078,13 @@
           <p:nvPr/>
         </p:nvPicPr>
         <p:blipFill>
-          <a:blip r:embed="rId3"/>
+          <a:blip r:embed="rId4">
+            <a:extLst>
+              <a:ext uri="{96DAC541-7B7A-43D3-8B79-37D633B846F1}">
+                <asvg:svgBlip xmlns:asvg="http://schemas.microsoft.com/office/drawing/2016/SVG/main" r:embed="rId5"/>
+              </a:ext>
+            </a:extLst>
+          </a:blip>
           <a:stretch>
             <a:fillRect/>
           </a:stretch>
@@ -16704,7 +17226,13 @@
           <p:nvPr/>
         </p:nvPicPr>
         <p:blipFill>
-          <a:blip r:embed="rId4"/>
+          <a:blip r:embed="rId6">
+            <a:extLst>
+              <a:ext uri="{96DAC541-7B7A-43D3-8B79-37D633B846F1}">
+                <asvg:svgBlip xmlns:asvg="http://schemas.microsoft.com/office/drawing/2016/SVG/main" r:embed="rId7"/>
+              </a:ext>
+            </a:extLst>
+          </a:blip>
           <a:stretch>
             <a:fillRect/>
           </a:stretch>
@@ -16918,7 +17446,7 @@
                 </a:solidFill>
                 <a:latin typeface="Microsoft YaHei"/>
               </a:rPr>
-              <a:t>色:深蓝灰   ·   一页 12 图</a:t>
+              <a:t>色:深蓝灰   ·   一页 12 图   ·   矢量</a:t>
             </a:r>
           </a:p>
         </p:txBody>
@@ -16980,7 +17508,13 @@
           <p:nvPr/>
         </p:nvPicPr>
         <p:blipFill>
-          <a:blip r:embed="rId2"/>
+          <a:blip r:embed="rId2">
+            <a:extLst>
+              <a:ext uri="{96DAC541-7B7A-43D3-8B79-37D633B846F1}">
+                <asvg:svgBlip xmlns:asvg="http://schemas.microsoft.com/office/drawing/2016/SVG/main" r:embed="rId3"/>
+              </a:ext>
+            </a:extLst>
+          </a:blip>
           <a:stretch>
             <a:fillRect/>
           </a:stretch>
@@ -17122,7 +17656,13 @@
           <p:nvPr/>
         </p:nvPicPr>
         <p:blipFill>
-          <a:blip r:embed="rId3"/>
+          <a:blip r:embed="rId4">
+            <a:extLst>
+              <a:ext uri="{96DAC541-7B7A-43D3-8B79-37D633B846F1}">
+                <asvg:svgBlip xmlns:asvg="http://schemas.microsoft.com/office/drawing/2016/SVG/main" r:embed="rId5"/>
+              </a:ext>
+            </a:extLst>
+          </a:blip>
           <a:stretch>
             <a:fillRect/>
           </a:stretch>
@@ -17264,7 +17804,13 @@
           <p:nvPr/>
         </p:nvPicPr>
         <p:blipFill>
-          <a:blip r:embed="rId4"/>
+          <a:blip r:embed="rId6">
+            <a:extLst>
+              <a:ext uri="{96DAC541-7B7A-43D3-8B79-37D633B846F1}">
+                <asvg:svgBlip xmlns:asvg="http://schemas.microsoft.com/office/drawing/2016/SVG/main" r:embed="rId7"/>
+              </a:ext>
+            </a:extLst>
+          </a:blip>
           <a:stretch>
             <a:fillRect/>
           </a:stretch>
@@ -17406,7 +17952,13 @@
           <p:nvPr/>
         </p:nvPicPr>
         <p:blipFill>
-          <a:blip r:embed="rId5"/>
+          <a:blip r:embed="rId8">
+            <a:extLst>
+              <a:ext uri="{96DAC541-7B7A-43D3-8B79-37D633B846F1}">
+                <asvg:svgBlip xmlns:asvg="http://schemas.microsoft.com/office/drawing/2016/SVG/main" r:embed="rId9"/>
+              </a:ext>
+            </a:extLst>
+          </a:blip>
           <a:stretch>
             <a:fillRect/>
           </a:stretch>
@@ -17548,7 +18100,13 @@
           <p:nvPr/>
         </p:nvPicPr>
         <p:blipFill>
-          <a:blip r:embed="rId6"/>
+          <a:blip r:embed="rId10">
+            <a:extLst>
+              <a:ext uri="{96DAC541-7B7A-43D3-8B79-37D633B846F1}">
+                <asvg:svgBlip xmlns:asvg="http://schemas.microsoft.com/office/drawing/2016/SVG/main" r:embed="rId11"/>
+              </a:ext>
+            </a:extLst>
+          </a:blip>
           <a:stretch>
             <a:fillRect/>
           </a:stretch>
@@ -17690,7 +18248,13 @@
           <p:nvPr/>
         </p:nvPicPr>
         <p:blipFill>
-          <a:blip r:embed="rId7"/>
+          <a:blip r:embed="rId12">
+            <a:extLst>
+              <a:ext uri="{96DAC541-7B7A-43D3-8B79-37D633B846F1}">
+                <asvg:svgBlip xmlns:asvg="http://schemas.microsoft.com/office/drawing/2016/SVG/main" r:embed="rId13"/>
+              </a:ext>
+            </a:extLst>
+          </a:blip>
           <a:stretch>
             <a:fillRect/>
           </a:stretch>
@@ -17832,7 +18396,13 @@
           <p:nvPr/>
         </p:nvPicPr>
         <p:blipFill>
-          <a:blip r:embed="rId8"/>
+          <a:blip r:embed="rId14">
+            <a:extLst>
+              <a:ext uri="{96DAC541-7B7A-43D3-8B79-37D633B846F1}">
+                <asvg:svgBlip xmlns:asvg="http://schemas.microsoft.com/office/drawing/2016/SVG/main" r:embed="rId15"/>
+              </a:ext>
+            </a:extLst>
+          </a:blip>
           <a:stretch>
             <a:fillRect/>
           </a:stretch>
@@ -17974,7 +18544,13 @@
           <p:nvPr/>
         </p:nvPicPr>
         <p:blipFill>
-          <a:blip r:embed="rId9"/>
+          <a:blip r:embed="rId16">
+            <a:extLst>
+              <a:ext uri="{96DAC541-7B7A-43D3-8B79-37D633B846F1}">
+                <asvg:svgBlip xmlns:asvg="http://schemas.microsoft.com/office/drawing/2016/SVG/main" r:embed="rId17"/>
+              </a:ext>
+            </a:extLst>
+          </a:blip>
           <a:stretch>
             <a:fillRect/>
           </a:stretch>
@@ -18116,7 +18692,13 @@
           <p:nvPr/>
         </p:nvPicPr>
         <p:blipFill>
-          <a:blip r:embed="rId10"/>
+          <a:blip r:embed="rId18">
+            <a:extLst>
+              <a:ext uri="{96DAC541-7B7A-43D3-8B79-37D633B846F1}">
+                <asvg:svgBlip xmlns:asvg="http://schemas.microsoft.com/office/drawing/2016/SVG/main" r:embed="rId19"/>
+              </a:ext>
+            </a:extLst>
+          </a:blip>
           <a:stretch>
             <a:fillRect/>
           </a:stretch>
@@ -18258,7 +18840,13 @@
           <p:nvPr/>
         </p:nvPicPr>
         <p:blipFill>
-          <a:blip r:embed="rId11"/>
+          <a:blip r:embed="rId20">
+            <a:extLst>
+              <a:ext uri="{96DAC541-7B7A-43D3-8B79-37D633B846F1}">
+                <asvg:svgBlip xmlns:asvg="http://schemas.microsoft.com/office/drawing/2016/SVG/main" r:embed="rId21"/>
+              </a:ext>
+            </a:extLst>
+          </a:blip>
           <a:stretch>
             <a:fillRect/>
           </a:stretch>
@@ -18400,7 +18988,13 @@
           <p:nvPr/>
         </p:nvPicPr>
         <p:blipFill>
-          <a:blip r:embed="rId12"/>
+          <a:blip r:embed="rId22">
+            <a:extLst>
+              <a:ext uri="{96DAC541-7B7A-43D3-8B79-37D633B846F1}">
+                <asvg:svgBlip xmlns:asvg="http://schemas.microsoft.com/office/drawing/2016/SVG/main" r:embed="rId23"/>
+              </a:ext>
+            </a:extLst>
+          </a:blip>
           <a:stretch>
             <a:fillRect/>
           </a:stretch>
@@ -18542,7 +19136,13 @@
           <p:nvPr/>
         </p:nvPicPr>
         <p:blipFill>
-          <a:blip r:embed="rId13"/>
+          <a:blip r:embed="rId24">
+            <a:extLst>
+              <a:ext uri="{96DAC541-7B7A-43D3-8B79-37D633B846F1}">
+                <asvg:svgBlip xmlns:asvg="http://schemas.microsoft.com/office/drawing/2016/SVG/main" r:embed="rId25"/>
+              </a:ext>
+            </a:extLst>
+          </a:blip>
           <a:stretch>
             <a:fillRect/>
           </a:stretch>
@@ -18756,7 +19356,7 @@
                 </a:solidFill>
                 <a:latin typeface="Microsoft YaHei"/>
               </a:rPr>
-              <a:t>色:深蓝灰   ·   一页 12 图</a:t>
+              <a:t>色:深蓝灰   ·   一页 12 图   ·   矢量</a:t>
             </a:r>
           </a:p>
         </p:txBody>
@@ -18818,7 +19418,13 @@
           <p:nvPr/>
         </p:nvPicPr>
         <p:blipFill>
-          <a:blip r:embed="rId2"/>
+          <a:blip r:embed="rId2">
+            <a:extLst>
+              <a:ext uri="{96DAC541-7B7A-43D3-8B79-37D633B846F1}">
+                <asvg:svgBlip xmlns:asvg="http://schemas.microsoft.com/office/drawing/2016/SVG/main" r:embed="rId3"/>
+              </a:ext>
+            </a:extLst>
+          </a:blip>
           <a:stretch>
             <a:fillRect/>
           </a:stretch>
@@ -18960,7 +19566,13 @@
           <p:nvPr/>
         </p:nvPicPr>
         <p:blipFill>
-          <a:blip r:embed="rId3"/>
+          <a:blip r:embed="rId4">
+            <a:extLst>
+              <a:ext uri="{96DAC541-7B7A-43D3-8B79-37D633B846F1}">
+                <asvg:svgBlip xmlns:asvg="http://schemas.microsoft.com/office/drawing/2016/SVG/main" r:embed="rId5"/>
+              </a:ext>
+            </a:extLst>
+          </a:blip>
           <a:stretch>
             <a:fillRect/>
           </a:stretch>
@@ -19102,7 +19714,13 @@
           <p:nvPr/>
         </p:nvPicPr>
         <p:blipFill>
-          <a:blip r:embed="rId4"/>
+          <a:blip r:embed="rId6">
+            <a:extLst>
+              <a:ext uri="{96DAC541-7B7A-43D3-8B79-37D633B846F1}">
+                <asvg:svgBlip xmlns:asvg="http://schemas.microsoft.com/office/drawing/2016/SVG/main" r:embed="rId7"/>
+              </a:ext>
+            </a:extLst>
+          </a:blip>
           <a:stretch>
             <a:fillRect/>
           </a:stretch>
@@ -19244,7 +19862,13 @@
           <p:nvPr/>
         </p:nvPicPr>
         <p:blipFill>
-          <a:blip r:embed="rId5"/>
+          <a:blip r:embed="rId8">
+            <a:extLst>
+              <a:ext uri="{96DAC541-7B7A-43D3-8B79-37D633B846F1}">
+                <asvg:svgBlip xmlns:asvg="http://schemas.microsoft.com/office/drawing/2016/SVG/main" r:embed="rId9"/>
+              </a:ext>
+            </a:extLst>
+          </a:blip>
           <a:stretch>
             <a:fillRect/>
           </a:stretch>
@@ -19386,7 +20010,13 @@
           <p:nvPr/>
         </p:nvPicPr>
         <p:blipFill>
-          <a:blip r:embed="rId6"/>
+          <a:blip r:embed="rId10">
+            <a:extLst>
+              <a:ext uri="{96DAC541-7B7A-43D3-8B79-37D633B846F1}">
+                <asvg:svgBlip xmlns:asvg="http://schemas.microsoft.com/office/drawing/2016/SVG/main" r:embed="rId11"/>
+              </a:ext>
+            </a:extLst>
+          </a:blip>
           <a:stretch>
             <a:fillRect/>
           </a:stretch>
@@ -19528,7 +20158,13 @@
           <p:nvPr/>
         </p:nvPicPr>
         <p:blipFill>
-          <a:blip r:embed="rId7"/>
+          <a:blip r:embed="rId12">
+            <a:extLst>
+              <a:ext uri="{96DAC541-7B7A-43D3-8B79-37D633B846F1}">
+                <asvg:svgBlip xmlns:asvg="http://schemas.microsoft.com/office/drawing/2016/SVG/main" r:embed="rId13"/>
+              </a:ext>
+            </a:extLst>
+          </a:blip>
           <a:stretch>
             <a:fillRect/>
           </a:stretch>
@@ -19670,7 +20306,13 @@
           <p:nvPr/>
         </p:nvPicPr>
         <p:blipFill>
-          <a:blip r:embed="rId8"/>
+          <a:blip r:embed="rId14">
+            <a:extLst>
+              <a:ext uri="{96DAC541-7B7A-43D3-8B79-37D633B846F1}">
+                <asvg:svgBlip xmlns:asvg="http://schemas.microsoft.com/office/drawing/2016/SVG/main" r:embed="rId15"/>
+              </a:ext>
+            </a:extLst>
+          </a:blip>
           <a:stretch>
             <a:fillRect/>
           </a:stretch>
@@ -19812,7 +20454,13 @@
           <p:nvPr/>
         </p:nvPicPr>
         <p:blipFill>
-          <a:blip r:embed="rId9"/>
+          <a:blip r:embed="rId16">
+            <a:extLst>
+              <a:ext uri="{96DAC541-7B7A-43D3-8B79-37D633B846F1}">
+                <asvg:svgBlip xmlns:asvg="http://schemas.microsoft.com/office/drawing/2016/SVG/main" r:embed="rId17"/>
+              </a:ext>
+            </a:extLst>
+          </a:blip>
           <a:stretch>
             <a:fillRect/>
           </a:stretch>
@@ -19954,7 +20602,13 @@
           <p:nvPr/>
         </p:nvPicPr>
         <p:blipFill>
-          <a:blip r:embed="rId10"/>
+          <a:blip r:embed="rId18">
+            <a:extLst>
+              <a:ext uri="{96DAC541-7B7A-43D3-8B79-37D633B846F1}">
+                <asvg:svgBlip xmlns:asvg="http://schemas.microsoft.com/office/drawing/2016/SVG/main" r:embed="rId19"/>
+              </a:ext>
+            </a:extLst>
+          </a:blip>
           <a:stretch>
             <a:fillRect/>
           </a:stretch>
@@ -20096,7 +20750,13 @@
           <p:nvPr/>
         </p:nvPicPr>
         <p:blipFill>
-          <a:blip r:embed="rId11"/>
+          <a:blip r:embed="rId20">
+            <a:extLst>
+              <a:ext uri="{96DAC541-7B7A-43D3-8B79-37D633B846F1}">
+                <asvg:svgBlip xmlns:asvg="http://schemas.microsoft.com/office/drawing/2016/SVG/main" r:embed="rId21"/>
+              </a:ext>
+            </a:extLst>
+          </a:blip>
           <a:stretch>
             <a:fillRect/>
           </a:stretch>
@@ -20238,7 +20898,13 @@
           <p:nvPr/>
         </p:nvPicPr>
         <p:blipFill>
-          <a:blip r:embed="rId12"/>
+          <a:blip r:embed="rId22">
+            <a:extLst>
+              <a:ext uri="{96DAC541-7B7A-43D3-8B79-37D633B846F1}">
+                <asvg:svgBlip xmlns:asvg="http://schemas.microsoft.com/office/drawing/2016/SVG/main" r:embed="rId23"/>
+              </a:ext>
+            </a:extLst>
+          </a:blip>
           <a:stretch>
             <a:fillRect/>
           </a:stretch>
@@ -20380,7 +21046,13 @@
           <p:nvPr/>
         </p:nvPicPr>
         <p:blipFill>
-          <a:blip r:embed="rId13"/>
+          <a:blip r:embed="rId24">
+            <a:extLst>
+              <a:ext uri="{96DAC541-7B7A-43D3-8B79-37D633B846F1}">
+                <asvg:svgBlip xmlns:asvg="http://schemas.microsoft.com/office/drawing/2016/SVG/main" r:embed="rId25"/>
+              </a:ext>
+            </a:extLst>
+          </a:blip>
           <a:stretch>
             <a:fillRect/>
           </a:stretch>
@@ -20594,7 +21266,7 @@
                 </a:solidFill>
                 <a:latin typeface="Microsoft YaHei"/>
               </a:rPr>
-              <a:t>色:深蓝灰   ·   一页 12 图</a:t>
+              <a:t>色:深蓝灰   ·   一页 12 图   ·   矢量</a:t>
             </a:r>
           </a:p>
         </p:txBody>
@@ -20656,7 +21328,13 @@
           <p:nvPr/>
         </p:nvPicPr>
         <p:blipFill>
-          <a:blip r:embed="rId2"/>
+          <a:blip r:embed="rId2">
+            <a:extLst>
+              <a:ext uri="{96DAC541-7B7A-43D3-8B79-37D633B846F1}">
+                <asvg:svgBlip xmlns:asvg="http://schemas.microsoft.com/office/drawing/2016/SVG/main" r:embed="rId3"/>
+              </a:ext>
+            </a:extLst>
+          </a:blip>
           <a:stretch>
             <a:fillRect/>
           </a:stretch>
@@ -20798,7 +21476,13 @@
           <p:nvPr/>
         </p:nvPicPr>
         <p:blipFill>
-          <a:blip r:embed="rId3"/>
+          <a:blip r:embed="rId4">
+            <a:extLst>
+              <a:ext uri="{96DAC541-7B7A-43D3-8B79-37D633B846F1}">
+                <asvg:svgBlip xmlns:asvg="http://schemas.microsoft.com/office/drawing/2016/SVG/main" r:embed="rId5"/>
+              </a:ext>
+            </a:extLst>
+          </a:blip>
           <a:stretch>
             <a:fillRect/>
           </a:stretch>
@@ -20940,7 +21624,13 @@
           <p:nvPr/>
         </p:nvPicPr>
         <p:blipFill>
-          <a:blip r:embed="rId4"/>
+          <a:blip r:embed="rId6">
+            <a:extLst>
+              <a:ext uri="{96DAC541-7B7A-43D3-8B79-37D633B846F1}">
+                <asvg:svgBlip xmlns:asvg="http://schemas.microsoft.com/office/drawing/2016/SVG/main" r:embed="rId7"/>
+              </a:ext>
+            </a:extLst>
+          </a:blip>
           <a:stretch>
             <a:fillRect/>
           </a:stretch>
@@ -21082,7 +21772,13 @@
           <p:nvPr/>
         </p:nvPicPr>
         <p:blipFill>
-          <a:blip r:embed="rId5"/>
+          <a:blip r:embed="rId8">
+            <a:extLst>
+              <a:ext uri="{96DAC541-7B7A-43D3-8B79-37D633B846F1}">
+                <asvg:svgBlip xmlns:asvg="http://schemas.microsoft.com/office/drawing/2016/SVG/main" r:embed="rId9"/>
+              </a:ext>
+            </a:extLst>
+          </a:blip>
           <a:stretch>
             <a:fillRect/>
           </a:stretch>
@@ -21224,7 +21920,13 @@
           <p:nvPr/>
         </p:nvPicPr>
         <p:blipFill>
-          <a:blip r:embed="rId6"/>
+          <a:blip r:embed="rId10">
+            <a:extLst>
+              <a:ext uri="{96DAC541-7B7A-43D3-8B79-37D633B846F1}">
+                <asvg:svgBlip xmlns:asvg="http://schemas.microsoft.com/office/drawing/2016/SVG/main" r:embed="rId11"/>
+              </a:ext>
+            </a:extLst>
+          </a:blip>
           <a:stretch>
             <a:fillRect/>
           </a:stretch>
@@ -21366,7 +22068,13 @@
           <p:nvPr/>
         </p:nvPicPr>
         <p:blipFill>
-          <a:blip r:embed="rId7"/>
+          <a:blip r:embed="rId12">
+            <a:extLst>
+              <a:ext uri="{96DAC541-7B7A-43D3-8B79-37D633B846F1}">
+                <asvg:svgBlip xmlns:asvg="http://schemas.microsoft.com/office/drawing/2016/SVG/main" r:embed="rId13"/>
+              </a:ext>
+            </a:extLst>
+          </a:blip>
           <a:stretch>
             <a:fillRect/>
           </a:stretch>
@@ -21508,7 +22216,13 @@
           <p:nvPr/>
         </p:nvPicPr>
         <p:blipFill>
-          <a:blip r:embed="rId8"/>
+          <a:blip r:embed="rId14">
+            <a:extLst>
+              <a:ext uri="{96DAC541-7B7A-43D3-8B79-37D633B846F1}">
+                <asvg:svgBlip xmlns:asvg="http://schemas.microsoft.com/office/drawing/2016/SVG/main" r:embed="rId15"/>
+              </a:ext>
+            </a:extLst>
+          </a:blip>
           <a:stretch>
             <a:fillRect/>
           </a:stretch>
@@ -21650,7 +22364,13 @@
           <p:nvPr/>
         </p:nvPicPr>
         <p:blipFill>
-          <a:blip r:embed="rId9"/>
+          <a:blip r:embed="rId16">
+            <a:extLst>
+              <a:ext uri="{96DAC541-7B7A-43D3-8B79-37D633B846F1}">
+                <asvg:svgBlip xmlns:asvg="http://schemas.microsoft.com/office/drawing/2016/SVG/main" r:embed="rId17"/>
+              </a:ext>
+            </a:extLst>
+          </a:blip>
           <a:stretch>
             <a:fillRect/>
           </a:stretch>
@@ -21792,7 +22512,13 @@
           <p:nvPr/>
         </p:nvPicPr>
         <p:blipFill>
-          <a:blip r:embed="rId10"/>
+          <a:blip r:embed="rId18">
+            <a:extLst>
+              <a:ext uri="{96DAC541-7B7A-43D3-8B79-37D633B846F1}">
+                <asvg:svgBlip xmlns:asvg="http://schemas.microsoft.com/office/drawing/2016/SVG/main" r:embed="rId19"/>
+              </a:ext>
+            </a:extLst>
+          </a:blip>
           <a:stretch>
             <a:fillRect/>
           </a:stretch>
@@ -21934,7 +22660,13 @@
           <p:nvPr/>
         </p:nvPicPr>
         <p:blipFill>
-          <a:blip r:embed="rId11"/>
+          <a:blip r:embed="rId20">
+            <a:extLst>
+              <a:ext uri="{96DAC541-7B7A-43D3-8B79-37D633B846F1}">
+                <asvg:svgBlip xmlns:asvg="http://schemas.microsoft.com/office/drawing/2016/SVG/main" r:embed="rId21"/>
+              </a:ext>
+            </a:extLst>
+          </a:blip>
           <a:stretch>
             <a:fillRect/>
           </a:stretch>
@@ -22076,7 +22808,13 @@
           <p:nvPr/>
         </p:nvPicPr>
         <p:blipFill>
-          <a:blip r:embed="rId12"/>
+          <a:blip r:embed="rId22">
+            <a:extLst>
+              <a:ext uri="{96DAC541-7B7A-43D3-8B79-37D633B846F1}">
+                <asvg:svgBlip xmlns:asvg="http://schemas.microsoft.com/office/drawing/2016/SVG/main" r:embed="rId23"/>
+              </a:ext>
+            </a:extLst>
+          </a:blip>
           <a:stretch>
             <a:fillRect/>
           </a:stretch>
@@ -22218,7 +22956,13 @@
           <p:nvPr/>
         </p:nvPicPr>
         <p:blipFill>
-          <a:blip r:embed="rId13"/>
+          <a:blip r:embed="rId24">
+            <a:extLst>
+              <a:ext uri="{96DAC541-7B7A-43D3-8B79-37D633B846F1}">
+                <asvg:svgBlip xmlns:asvg="http://schemas.microsoft.com/office/drawing/2016/SVG/main" r:embed="rId25"/>
+              </a:ext>
+            </a:extLst>
+          </a:blip>
           <a:stretch>
             <a:fillRect/>
           </a:stretch>

</xml_diff>